<commit_message>
Doc atualização Power Point
</commit_message>
<xml_diff>
--- a/Documentacao/ArquiteturaProjeto.pptx
+++ b/Documentacao/ArquiteturaProjeto.pptx
@@ -8,6 +8,7 @@
     <p:sldId id="256" r:id="rId2"/>
     <p:sldId id="257" r:id="rId3"/>
     <p:sldId id="259" r:id="rId4"/>
+    <p:sldId id="260" r:id="rId5"/>
   </p:sldIdLst>
   <p:sldSz cx="12192000" cy="6858000"/>
   <p:notesSz cx="6858000" cy="9144000"/>
@@ -156,10 +157,9 @@
           </a:lstStyle>
           <a:p>
             <a:r>
-              <a:rPr lang="pt-BR" smtClean="0"/>
+              <a:rPr lang="pt-BR"/>
               <a:t>Clique para editar o título mestre</a:t>
             </a:r>
-            <a:endParaRPr lang="pt-BR"/>
           </a:p>
         </p:txBody>
       </p:sp>
@@ -221,10 +221,9 @@
           </a:lstStyle>
           <a:p>
             <a:r>
-              <a:rPr lang="pt-BR" smtClean="0"/>
+              <a:rPr lang="pt-BR"/>
               <a:t>Clique para editar o estilo do subtítulo Mestre</a:t>
             </a:r>
-            <a:endParaRPr lang="pt-BR"/>
           </a:p>
         </p:txBody>
       </p:sp>
@@ -245,7 +244,7 @@
           <a:p>
             <a:fld id="{F3723911-63F9-4D1B-B658-668BA8A96493}" type="datetimeFigureOut">
               <a:rPr lang="pt-BR" smtClean="0"/>
-              <a:t>22/05/2026</a:t>
+              <a:t>10/06/2026</a:t>
             </a:fld>
             <a:endParaRPr lang="pt-BR"/>
           </a:p>
@@ -339,10 +338,9 @@
           <a:lstStyle/>
           <a:p>
             <a:r>
-              <a:rPr lang="pt-BR" smtClean="0"/>
+              <a:rPr lang="pt-BR"/>
               <a:t>Clique para editar o título mestre</a:t>
             </a:r>
-            <a:endParaRPr lang="pt-BR"/>
           </a:p>
         </p:txBody>
       </p:sp>
@@ -363,38 +361,37 @@
           <a:p>
             <a:pPr lvl="0"/>
             <a:r>
-              <a:rPr lang="pt-BR" smtClean="0"/>
+              <a:rPr lang="pt-BR"/>
               <a:t>Editar estilos de texto Mestre</a:t>
             </a:r>
           </a:p>
           <a:p>
             <a:pPr lvl="1"/>
             <a:r>
-              <a:rPr lang="pt-BR" smtClean="0"/>
+              <a:rPr lang="pt-BR"/>
               <a:t>Segundo nível</a:t>
             </a:r>
           </a:p>
           <a:p>
             <a:pPr lvl="2"/>
             <a:r>
-              <a:rPr lang="pt-BR" smtClean="0"/>
+              <a:rPr lang="pt-BR"/>
               <a:t>Terceiro nível</a:t>
             </a:r>
           </a:p>
           <a:p>
             <a:pPr lvl="3"/>
             <a:r>
-              <a:rPr lang="pt-BR" smtClean="0"/>
+              <a:rPr lang="pt-BR"/>
               <a:t>Quarto nível</a:t>
             </a:r>
           </a:p>
           <a:p>
             <a:pPr lvl="4"/>
             <a:r>
-              <a:rPr lang="pt-BR" smtClean="0"/>
+              <a:rPr lang="pt-BR"/>
               <a:t>Quinto nível</a:t>
             </a:r>
-            <a:endParaRPr lang="pt-BR"/>
           </a:p>
         </p:txBody>
       </p:sp>
@@ -415,7 +412,7 @@
           <a:p>
             <a:fld id="{F3723911-63F9-4D1B-B658-668BA8A96493}" type="datetimeFigureOut">
               <a:rPr lang="pt-BR" smtClean="0"/>
-              <a:t>22/05/2026</a:t>
+              <a:t>10/06/2026</a:t>
             </a:fld>
             <a:endParaRPr lang="pt-BR"/>
           </a:p>
@@ -514,10 +511,9 @@
           <a:lstStyle/>
           <a:p>
             <a:r>
-              <a:rPr lang="pt-BR" smtClean="0"/>
+              <a:rPr lang="pt-BR"/>
               <a:t>Clique para editar o título mestre</a:t>
             </a:r>
-            <a:endParaRPr lang="pt-BR"/>
           </a:p>
         </p:txBody>
       </p:sp>
@@ -543,38 +539,37 @@
           <a:p>
             <a:pPr lvl="0"/>
             <a:r>
-              <a:rPr lang="pt-BR" smtClean="0"/>
+              <a:rPr lang="pt-BR"/>
               <a:t>Editar estilos de texto Mestre</a:t>
             </a:r>
           </a:p>
           <a:p>
             <a:pPr lvl="1"/>
             <a:r>
-              <a:rPr lang="pt-BR" smtClean="0"/>
+              <a:rPr lang="pt-BR"/>
               <a:t>Segundo nível</a:t>
             </a:r>
           </a:p>
           <a:p>
             <a:pPr lvl="2"/>
             <a:r>
-              <a:rPr lang="pt-BR" smtClean="0"/>
+              <a:rPr lang="pt-BR"/>
               <a:t>Terceiro nível</a:t>
             </a:r>
           </a:p>
           <a:p>
             <a:pPr lvl="3"/>
             <a:r>
-              <a:rPr lang="pt-BR" smtClean="0"/>
+              <a:rPr lang="pt-BR"/>
               <a:t>Quarto nível</a:t>
             </a:r>
           </a:p>
           <a:p>
             <a:pPr lvl="4"/>
             <a:r>
-              <a:rPr lang="pt-BR" smtClean="0"/>
+              <a:rPr lang="pt-BR"/>
               <a:t>Quinto nível</a:t>
             </a:r>
-            <a:endParaRPr lang="pt-BR"/>
           </a:p>
         </p:txBody>
       </p:sp>
@@ -595,7 +590,7 @@
           <a:p>
             <a:fld id="{F3723911-63F9-4D1B-B658-668BA8A96493}" type="datetimeFigureOut">
               <a:rPr lang="pt-BR" smtClean="0"/>
-              <a:t>22/05/2026</a:t>
+              <a:t>10/06/2026</a:t>
             </a:fld>
             <a:endParaRPr lang="pt-BR"/>
           </a:p>
@@ -689,10 +684,9 @@
           <a:lstStyle/>
           <a:p>
             <a:r>
-              <a:rPr lang="pt-BR" smtClean="0"/>
+              <a:rPr lang="pt-BR"/>
               <a:t>Clique para editar o título mestre</a:t>
             </a:r>
-            <a:endParaRPr lang="pt-BR"/>
           </a:p>
         </p:txBody>
       </p:sp>
@@ -713,38 +707,37 @@
           <a:p>
             <a:pPr lvl="0"/>
             <a:r>
-              <a:rPr lang="pt-BR" smtClean="0"/>
+              <a:rPr lang="pt-BR"/>
               <a:t>Editar estilos de texto Mestre</a:t>
             </a:r>
           </a:p>
           <a:p>
             <a:pPr lvl="1"/>
             <a:r>
-              <a:rPr lang="pt-BR" smtClean="0"/>
+              <a:rPr lang="pt-BR"/>
               <a:t>Segundo nível</a:t>
             </a:r>
           </a:p>
           <a:p>
             <a:pPr lvl="2"/>
             <a:r>
-              <a:rPr lang="pt-BR" smtClean="0"/>
+              <a:rPr lang="pt-BR"/>
               <a:t>Terceiro nível</a:t>
             </a:r>
           </a:p>
           <a:p>
             <a:pPr lvl="3"/>
             <a:r>
-              <a:rPr lang="pt-BR" smtClean="0"/>
+              <a:rPr lang="pt-BR"/>
               <a:t>Quarto nível</a:t>
             </a:r>
           </a:p>
           <a:p>
             <a:pPr lvl="4"/>
             <a:r>
-              <a:rPr lang="pt-BR" smtClean="0"/>
+              <a:rPr lang="pt-BR"/>
               <a:t>Quinto nível</a:t>
             </a:r>
-            <a:endParaRPr lang="pt-BR"/>
           </a:p>
         </p:txBody>
       </p:sp>
@@ -765,7 +758,7 @@
           <a:p>
             <a:fld id="{F3723911-63F9-4D1B-B658-668BA8A96493}" type="datetimeFigureOut">
               <a:rPr lang="pt-BR" smtClean="0"/>
-              <a:t>22/05/2026</a:t>
+              <a:t>10/06/2026</a:t>
             </a:fld>
             <a:endParaRPr lang="pt-BR"/>
           </a:p>
@@ -868,10 +861,9 @@
           </a:lstStyle>
           <a:p>
             <a:r>
-              <a:rPr lang="pt-BR" smtClean="0"/>
+              <a:rPr lang="pt-BR"/>
               <a:t>Clique para editar o título mestre</a:t>
             </a:r>
-            <a:endParaRPr lang="pt-BR"/>
           </a:p>
         </p:txBody>
       </p:sp>
@@ -988,7 +980,7 @@
           <a:p>
             <a:pPr lvl="0"/>
             <a:r>
-              <a:rPr lang="pt-BR" smtClean="0"/>
+              <a:rPr lang="pt-BR"/>
               <a:t>Editar estilos de texto Mestre</a:t>
             </a:r>
           </a:p>
@@ -1011,7 +1003,7 @@
           <a:p>
             <a:fld id="{F3723911-63F9-4D1B-B658-668BA8A96493}" type="datetimeFigureOut">
               <a:rPr lang="pt-BR" smtClean="0"/>
-              <a:t>22/05/2026</a:t>
+              <a:t>10/06/2026</a:t>
             </a:fld>
             <a:endParaRPr lang="pt-BR"/>
           </a:p>
@@ -1105,10 +1097,9 @@
           <a:lstStyle/>
           <a:p>
             <a:r>
-              <a:rPr lang="pt-BR" smtClean="0"/>
+              <a:rPr lang="pt-BR"/>
               <a:t>Clique para editar o título mestre</a:t>
             </a:r>
-            <a:endParaRPr lang="pt-BR"/>
           </a:p>
         </p:txBody>
       </p:sp>
@@ -1134,38 +1125,37 @@
           <a:p>
             <a:pPr lvl="0"/>
             <a:r>
-              <a:rPr lang="pt-BR" smtClean="0"/>
+              <a:rPr lang="pt-BR"/>
               <a:t>Editar estilos de texto Mestre</a:t>
             </a:r>
           </a:p>
           <a:p>
             <a:pPr lvl="1"/>
             <a:r>
-              <a:rPr lang="pt-BR" smtClean="0"/>
+              <a:rPr lang="pt-BR"/>
               <a:t>Segundo nível</a:t>
             </a:r>
           </a:p>
           <a:p>
             <a:pPr lvl="2"/>
             <a:r>
-              <a:rPr lang="pt-BR" smtClean="0"/>
+              <a:rPr lang="pt-BR"/>
               <a:t>Terceiro nível</a:t>
             </a:r>
           </a:p>
           <a:p>
             <a:pPr lvl="3"/>
             <a:r>
-              <a:rPr lang="pt-BR" smtClean="0"/>
+              <a:rPr lang="pt-BR"/>
               <a:t>Quarto nível</a:t>
             </a:r>
           </a:p>
           <a:p>
             <a:pPr lvl="4"/>
             <a:r>
-              <a:rPr lang="pt-BR" smtClean="0"/>
+              <a:rPr lang="pt-BR"/>
               <a:t>Quinto nível</a:t>
             </a:r>
-            <a:endParaRPr lang="pt-BR"/>
           </a:p>
         </p:txBody>
       </p:sp>
@@ -1191,38 +1181,37 @@
           <a:p>
             <a:pPr lvl="0"/>
             <a:r>
-              <a:rPr lang="pt-BR" smtClean="0"/>
+              <a:rPr lang="pt-BR"/>
               <a:t>Editar estilos de texto Mestre</a:t>
             </a:r>
           </a:p>
           <a:p>
             <a:pPr lvl="1"/>
             <a:r>
-              <a:rPr lang="pt-BR" smtClean="0"/>
+              <a:rPr lang="pt-BR"/>
               <a:t>Segundo nível</a:t>
             </a:r>
           </a:p>
           <a:p>
             <a:pPr lvl="2"/>
             <a:r>
-              <a:rPr lang="pt-BR" smtClean="0"/>
+              <a:rPr lang="pt-BR"/>
               <a:t>Terceiro nível</a:t>
             </a:r>
           </a:p>
           <a:p>
             <a:pPr lvl="3"/>
             <a:r>
-              <a:rPr lang="pt-BR" smtClean="0"/>
+              <a:rPr lang="pt-BR"/>
               <a:t>Quarto nível</a:t>
             </a:r>
           </a:p>
           <a:p>
             <a:pPr lvl="4"/>
             <a:r>
-              <a:rPr lang="pt-BR" smtClean="0"/>
+              <a:rPr lang="pt-BR"/>
               <a:t>Quinto nível</a:t>
             </a:r>
-            <a:endParaRPr lang="pt-BR"/>
           </a:p>
         </p:txBody>
       </p:sp>
@@ -1243,7 +1232,7 @@
           <a:p>
             <a:fld id="{F3723911-63F9-4D1B-B658-668BA8A96493}" type="datetimeFigureOut">
               <a:rPr lang="pt-BR" smtClean="0"/>
-              <a:t>22/05/2026</a:t>
+              <a:t>10/06/2026</a:t>
             </a:fld>
             <a:endParaRPr lang="pt-BR"/>
           </a:p>
@@ -1342,10 +1331,9 @@
           <a:lstStyle/>
           <a:p>
             <a:r>
-              <a:rPr lang="pt-BR" smtClean="0"/>
+              <a:rPr lang="pt-BR"/>
               <a:t>Clique para editar o título mestre</a:t>
             </a:r>
-            <a:endParaRPr lang="pt-BR"/>
           </a:p>
         </p:txBody>
       </p:sp>
@@ -1408,7 +1396,7 @@
           <a:p>
             <a:pPr lvl="0"/>
             <a:r>
-              <a:rPr lang="pt-BR" smtClean="0"/>
+              <a:rPr lang="pt-BR"/>
               <a:t>Editar estilos de texto Mestre</a:t>
             </a:r>
           </a:p>
@@ -1436,38 +1424,37 @@
           <a:p>
             <a:pPr lvl="0"/>
             <a:r>
-              <a:rPr lang="pt-BR" smtClean="0"/>
+              <a:rPr lang="pt-BR"/>
               <a:t>Editar estilos de texto Mestre</a:t>
             </a:r>
           </a:p>
           <a:p>
             <a:pPr lvl="1"/>
             <a:r>
-              <a:rPr lang="pt-BR" smtClean="0"/>
+              <a:rPr lang="pt-BR"/>
               <a:t>Segundo nível</a:t>
             </a:r>
           </a:p>
           <a:p>
             <a:pPr lvl="2"/>
             <a:r>
-              <a:rPr lang="pt-BR" smtClean="0"/>
+              <a:rPr lang="pt-BR"/>
               <a:t>Terceiro nível</a:t>
             </a:r>
           </a:p>
           <a:p>
             <a:pPr lvl="3"/>
             <a:r>
-              <a:rPr lang="pt-BR" smtClean="0"/>
+              <a:rPr lang="pt-BR"/>
               <a:t>Quarto nível</a:t>
             </a:r>
           </a:p>
           <a:p>
             <a:pPr lvl="4"/>
             <a:r>
-              <a:rPr lang="pt-BR" smtClean="0"/>
+              <a:rPr lang="pt-BR"/>
               <a:t>Quinto nível</a:t>
             </a:r>
-            <a:endParaRPr lang="pt-BR"/>
           </a:p>
         </p:txBody>
       </p:sp>
@@ -1530,7 +1517,7 @@
           <a:p>
             <a:pPr lvl="0"/>
             <a:r>
-              <a:rPr lang="pt-BR" smtClean="0"/>
+              <a:rPr lang="pt-BR"/>
               <a:t>Editar estilos de texto Mestre</a:t>
             </a:r>
           </a:p>
@@ -1558,38 +1545,37 @@
           <a:p>
             <a:pPr lvl="0"/>
             <a:r>
-              <a:rPr lang="pt-BR" smtClean="0"/>
+              <a:rPr lang="pt-BR"/>
               <a:t>Editar estilos de texto Mestre</a:t>
             </a:r>
           </a:p>
           <a:p>
             <a:pPr lvl="1"/>
             <a:r>
-              <a:rPr lang="pt-BR" smtClean="0"/>
+              <a:rPr lang="pt-BR"/>
               <a:t>Segundo nível</a:t>
             </a:r>
           </a:p>
           <a:p>
             <a:pPr lvl="2"/>
             <a:r>
-              <a:rPr lang="pt-BR" smtClean="0"/>
+              <a:rPr lang="pt-BR"/>
               <a:t>Terceiro nível</a:t>
             </a:r>
           </a:p>
           <a:p>
             <a:pPr lvl="3"/>
             <a:r>
-              <a:rPr lang="pt-BR" smtClean="0"/>
+              <a:rPr lang="pt-BR"/>
               <a:t>Quarto nível</a:t>
             </a:r>
           </a:p>
           <a:p>
             <a:pPr lvl="4"/>
             <a:r>
-              <a:rPr lang="pt-BR" smtClean="0"/>
+              <a:rPr lang="pt-BR"/>
               <a:t>Quinto nível</a:t>
             </a:r>
-            <a:endParaRPr lang="pt-BR"/>
           </a:p>
         </p:txBody>
       </p:sp>
@@ -1610,7 +1596,7 @@
           <a:p>
             <a:fld id="{F3723911-63F9-4D1B-B658-668BA8A96493}" type="datetimeFigureOut">
               <a:rPr lang="pt-BR" smtClean="0"/>
-              <a:t>22/05/2026</a:t>
+              <a:t>10/06/2026</a:t>
             </a:fld>
             <a:endParaRPr lang="pt-BR"/>
           </a:p>
@@ -1704,10 +1690,9 @@
           <a:lstStyle/>
           <a:p>
             <a:r>
-              <a:rPr lang="pt-BR" smtClean="0"/>
+              <a:rPr lang="pt-BR"/>
               <a:t>Clique para editar o título mestre</a:t>
             </a:r>
-            <a:endParaRPr lang="pt-BR"/>
           </a:p>
         </p:txBody>
       </p:sp>
@@ -1728,7 +1713,7 @@
           <a:p>
             <a:fld id="{F3723911-63F9-4D1B-B658-668BA8A96493}" type="datetimeFigureOut">
               <a:rPr lang="pt-BR" smtClean="0"/>
-              <a:t>22/05/2026</a:t>
+              <a:t>10/06/2026</a:t>
             </a:fld>
             <a:endParaRPr lang="pt-BR"/>
           </a:p>
@@ -1823,7 +1808,7 @@
           <a:p>
             <a:fld id="{F3723911-63F9-4D1B-B658-668BA8A96493}" type="datetimeFigureOut">
               <a:rPr lang="pt-BR" smtClean="0"/>
-              <a:t>22/05/2026</a:t>
+              <a:t>10/06/2026</a:t>
             </a:fld>
             <a:endParaRPr lang="pt-BR"/>
           </a:p>
@@ -1926,10 +1911,9 @@
           </a:lstStyle>
           <a:p>
             <a:r>
-              <a:rPr lang="pt-BR" smtClean="0"/>
+              <a:rPr lang="pt-BR"/>
               <a:t>Clique para editar o título mestre</a:t>
             </a:r>
-            <a:endParaRPr lang="pt-BR"/>
           </a:p>
         </p:txBody>
       </p:sp>
@@ -1983,38 +1967,37 @@
           <a:p>
             <a:pPr lvl="0"/>
             <a:r>
-              <a:rPr lang="pt-BR" smtClean="0"/>
+              <a:rPr lang="pt-BR"/>
               <a:t>Editar estilos de texto Mestre</a:t>
             </a:r>
           </a:p>
           <a:p>
             <a:pPr lvl="1"/>
             <a:r>
-              <a:rPr lang="pt-BR" smtClean="0"/>
+              <a:rPr lang="pt-BR"/>
               <a:t>Segundo nível</a:t>
             </a:r>
           </a:p>
           <a:p>
             <a:pPr lvl="2"/>
             <a:r>
-              <a:rPr lang="pt-BR" smtClean="0"/>
+              <a:rPr lang="pt-BR"/>
               <a:t>Terceiro nível</a:t>
             </a:r>
           </a:p>
           <a:p>
             <a:pPr lvl="3"/>
             <a:r>
-              <a:rPr lang="pt-BR" smtClean="0"/>
+              <a:rPr lang="pt-BR"/>
               <a:t>Quarto nível</a:t>
             </a:r>
           </a:p>
           <a:p>
             <a:pPr lvl="4"/>
             <a:r>
-              <a:rPr lang="pt-BR" smtClean="0"/>
+              <a:rPr lang="pt-BR"/>
               <a:t>Quinto nível</a:t>
             </a:r>
-            <a:endParaRPr lang="pt-BR"/>
           </a:p>
         </p:txBody>
       </p:sp>
@@ -2077,7 +2060,7 @@
           <a:p>
             <a:pPr lvl="0"/>
             <a:r>
-              <a:rPr lang="pt-BR" smtClean="0"/>
+              <a:rPr lang="pt-BR"/>
               <a:t>Editar estilos de texto Mestre</a:t>
             </a:r>
           </a:p>
@@ -2100,7 +2083,7 @@
           <a:p>
             <a:fld id="{F3723911-63F9-4D1B-B658-668BA8A96493}" type="datetimeFigureOut">
               <a:rPr lang="pt-BR" smtClean="0"/>
-              <a:t>22/05/2026</a:t>
+              <a:t>10/06/2026</a:t>
             </a:fld>
             <a:endParaRPr lang="pt-BR"/>
           </a:p>
@@ -2203,10 +2186,9 @@
           </a:lstStyle>
           <a:p>
             <a:r>
-              <a:rPr lang="pt-BR" smtClean="0"/>
+              <a:rPr lang="pt-BR"/>
               <a:t>Clique para editar o título mestre</a:t>
             </a:r>
-            <a:endParaRPr lang="pt-BR"/>
           </a:p>
         </p:txBody>
       </p:sp>
@@ -2330,7 +2312,7 @@
           <a:p>
             <a:pPr lvl="0"/>
             <a:r>
-              <a:rPr lang="pt-BR" smtClean="0"/>
+              <a:rPr lang="pt-BR"/>
               <a:t>Editar estilos de texto Mestre</a:t>
             </a:r>
           </a:p>
@@ -2353,7 +2335,7 @@
           <a:p>
             <a:fld id="{F3723911-63F9-4D1B-B658-668BA8A96493}" type="datetimeFigureOut">
               <a:rPr lang="pt-BR" smtClean="0"/>
-              <a:t>22/05/2026</a:t>
+              <a:t>10/06/2026</a:t>
             </a:fld>
             <a:endParaRPr lang="pt-BR"/>
           </a:p>
@@ -2462,10 +2444,9 @@
           <a:lstStyle/>
           <a:p>
             <a:r>
-              <a:rPr lang="pt-BR" smtClean="0"/>
+              <a:rPr lang="pt-BR"/>
               <a:t>Clique para editar o título mestre</a:t>
             </a:r>
-            <a:endParaRPr lang="pt-BR"/>
           </a:p>
         </p:txBody>
       </p:sp>
@@ -2496,38 +2477,37 @@
           <a:p>
             <a:pPr lvl="0"/>
             <a:r>
-              <a:rPr lang="pt-BR" smtClean="0"/>
+              <a:rPr lang="pt-BR"/>
               <a:t>Editar estilos de texto Mestre</a:t>
             </a:r>
           </a:p>
           <a:p>
             <a:pPr lvl="1"/>
             <a:r>
-              <a:rPr lang="pt-BR" smtClean="0"/>
+              <a:rPr lang="pt-BR"/>
               <a:t>Segundo nível</a:t>
             </a:r>
           </a:p>
           <a:p>
             <a:pPr lvl="2"/>
             <a:r>
-              <a:rPr lang="pt-BR" smtClean="0"/>
+              <a:rPr lang="pt-BR"/>
               <a:t>Terceiro nível</a:t>
             </a:r>
           </a:p>
           <a:p>
             <a:pPr lvl="3"/>
             <a:r>
-              <a:rPr lang="pt-BR" smtClean="0"/>
+              <a:rPr lang="pt-BR"/>
               <a:t>Quarto nível</a:t>
             </a:r>
           </a:p>
           <a:p>
             <a:pPr lvl="4"/>
             <a:r>
-              <a:rPr lang="pt-BR" smtClean="0"/>
+              <a:rPr lang="pt-BR"/>
               <a:t>Quinto nível</a:t>
             </a:r>
-            <a:endParaRPr lang="pt-BR"/>
           </a:p>
         </p:txBody>
       </p:sp>
@@ -2566,7 +2546,7 @@
           <a:p>
             <a:fld id="{F3723911-63F9-4D1B-B658-668BA8A96493}" type="datetimeFigureOut">
               <a:rPr lang="pt-BR" smtClean="0"/>
-              <a:t>22/05/2026</a:t>
+              <a:t>10/06/2026</a:t>
             </a:fld>
             <a:endParaRPr lang="pt-BR"/>
           </a:p>
@@ -2994,30 +2974,12 @@
           <a:lstStyle/>
           <a:p>
             <a:r>
-              <a:rPr lang="pt-BR" sz="4000" b="1" dirty="0" smtClean="0">
+              <a:rPr lang="pt-BR" sz="4000" b="1" dirty="0">
                 <a:latin typeface="Arial" panose="020B0604020202020204" pitchFamily="34" charset="0"/>
                 <a:cs typeface="Arial" panose="020B0604020202020204" pitchFamily="34" charset="0"/>
               </a:rPr>
-              <a:t>Orientações e Arquitetura </a:t>
-            </a:r>
-            <a:r>
-              <a:rPr lang="pt-BR" sz="4000" b="1" dirty="0" smtClean="0">
-                <a:latin typeface="Arial" panose="020B0604020202020204" pitchFamily="34" charset="0"/>
-                <a:cs typeface="Arial" panose="020B0604020202020204" pitchFamily="34" charset="0"/>
-              </a:rPr>
-              <a:t>do </a:t>
-            </a:r>
-            <a:r>
-              <a:rPr lang="pt-BR" sz="4000" b="1" dirty="0" smtClean="0">
-                <a:latin typeface="Arial" panose="020B0604020202020204" pitchFamily="34" charset="0"/>
-                <a:cs typeface="Arial" panose="020B0604020202020204" pitchFamily="34" charset="0"/>
-              </a:rPr>
-              <a:t>Projeto</a:t>
-            </a:r>
-            <a:endParaRPr lang="pt-BR" sz="4000" b="1" dirty="0">
-              <a:latin typeface="Arial" panose="020B0604020202020204" pitchFamily="34" charset="0"/>
-              <a:cs typeface="Arial" panose="020B0604020202020204" pitchFamily="34" charset="0"/>
-            </a:endParaRPr>
+              <a:t>Orientações e Arquitetura do Projeto</a:t>
+            </a:r>
           </a:p>
         </p:txBody>
       </p:sp>
@@ -3092,10 +3054,9 @@
           <a:lstStyle/>
           <a:p>
             <a:r>
-              <a:rPr lang="pt-BR" b="1" dirty="0" smtClean="0"/>
+              <a:rPr lang="pt-BR" b="1" dirty="0"/>
               <a:t>Banco SENAI</a:t>
             </a:r>
-            <a:endParaRPr lang="pt-BR" b="1" dirty="0"/>
           </a:p>
         </p:txBody>
       </p:sp>
@@ -3201,17 +3162,16 @@
           <a:p>
             <a:pPr algn="ctr"/>
             <a:r>
-              <a:rPr lang="pt-BR" dirty="0" smtClean="0"/>
+              <a:rPr lang="pt-BR" dirty="0"/>
               <a:t>Banco </a:t>
             </a:r>
           </a:p>
           <a:p>
             <a:pPr algn="ctr"/>
             <a:r>
-              <a:rPr lang="pt-BR" dirty="0" smtClean="0"/>
+              <a:rPr lang="pt-BR" dirty="0"/>
               <a:t>Central</a:t>
             </a:r>
-            <a:endParaRPr lang="pt-BR" dirty="0"/>
           </a:p>
         </p:txBody>
       </p:sp>
@@ -3238,10 +3198,9 @@
           <a:lstStyle/>
           <a:p>
             <a:r>
-              <a:rPr lang="pt-BR" dirty="0" smtClean="0"/>
+              <a:rPr lang="pt-BR" dirty="0"/>
               <a:t>Arquivos</a:t>
             </a:r>
-            <a:endParaRPr lang="pt-BR" dirty="0"/>
           </a:p>
         </p:txBody>
       </p:sp>
@@ -3348,10 +3307,9 @@
           <a:lstStyle/>
           <a:p>
             <a:r>
-              <a:rPr lang="pt-BR" dirty="0" smtClean="0"/>
+              <a:rPr lang="pt-BR" dirty="0"/>
               <a:t>Fintech</a:t>
             </a:r>
-            <a:endParaRPr lang="pt-BR" dirty="0"/>
           </a:p>
         </p:txBody>
       </p:sp>
@@ -3378,18 +3336,13 @@
           <a:lstStyle/>
           <a:p>
             <a:r>
-              <a:rPr lang="pt-BR" dirty="0" smtClean="0">
+              <a:rPr lang="pt-BR" dirty="0">
                 <a:solidFill>
                   <a:schemeClr val="bg1"/>
                 </a:solidFill>
               </a:rPr>
               <a:t>Endpoint</a:t>
             </a:r>
-            <a:endParaRPr lang="pt-BR" dirty="0">
-              <a:solidFill>
-                <a:schemeClr val="bg1"/>
-              </a:solidFill>
-            </a:endParaRPr>
           </a:p>
         </p:txBody>
       </p:sp>
@@ -3599,10 +3552,9 @@
           <a:lstStyle/>
           <a:p>
             <a:r>
-              <a:rPr lang="pt-BR" dirty="0" smtClean="0"/>
+              <a:rPr lang="pt-BR" dirty="0"/>
               <a:t>DB</a:t>
             </a:r>
-            <a:endParaRPr lang="pt-BR" dirty="0"/>
           </a:p>
         </p:txBody>
       </p:sp>
@@ -3672,18 +3624,13 @@
           <a:lstStyle/>
           <a:p>
             <a:r>
-              <a:rPr lang="pt-BR" dirty="0" smtClean="0">
+              <a:rPr lang="pt-BR" dirty="0">
                 <a:solidFill>
                   <a:schemeClr val="bg1"/>
                 </a:solidFill>
               </a:rPr>
               <a:t>BackEnd API</a:t>
             </a:r>
-            <a:endParaRPr lang="pt-BR" dirty="0">
-              <a:solidFill>
-                <a:schemeClr val="bg1"/>
-              </a:solidFill>
-            </a:endParaRPr>
           </a:p>
         </p:txBody>
       </p:sp>
@@ -3757,18 +3704,13 @@
           <a:lstStyle/>
           <a:p>
             <a:r>
-              <a:rPr lang="pt-BR" dirty="0" smtClean="0">
+              <a:rPr lang="pt-BR" dirty="0">
                 <a:solidFill>
                   <a:schemeClr val="bg1"/>
                 </a:solidFill>
               </a:rPr>
               <a:t>FrontEnd</a:t>
             </a:r>
-            <a:endParaRPr lang="pt-BR" dirty="0">
-              <a:solidFill>
-                <a:schemeClr val="bg1"/>
-              </a:solidFill>
-            </a:endParaRPr>
           </a:p>
         </p:txBody>
       </p:sp>
@@ -3795,10 +3737,9 @@
           <a:lstStyle/>
           <a:p>
             <a:r>
-              <a:rPr lang="pt-BR" dirty="0" smtClean="0"/>
+              <a:rPr lang="pt-BR" dirty="0"/>
               <a:t>MVC</a:t>
             </a:r>
-            <a:endParaRPr lang="pt-BR" dirty="0"/>
           </a:p>
         </p:txBody>
       </p:sp>
@@ -3909,10 +3850,9 @@
           <a:lstStyle/>
           <a:p>
             <a:r>
-              <a:rPr lang="pt-BR" dirty="0" smtClean="0"/>
+              <a:rPr lang="pt-BR" dirty="0"/>
               <a:t>SQUAD BI</a:t>
             </a:r>
-            <a:endParaRPr lang="pt-BR" dirty="0"/>
           </a:p>
         </p:txBody>
       </p:sp>
@@ -3976,10 +3916,9 @@
           <a:p>
             <a:pPr algn="ctr"/>
             <a:r>
-              <a:rPr lang="pt-BR" dirty="0" smtClean="0"/>
+              <a:rPr lang="pt-BR" dirty="0"/>
               <a:t>Analise de Dados</a:t>
             </a:r>
-            <a:endParaRPr lang="pt-BR" dirty="0"/>
           </a:p>
         </p:txBody>
       </p:sp>
@@ -4007,10 +3946,9 @@
           <a:p>
             <a:pPr algn="ctr"/>
             <a:r>
-              <a:rPr lang="pt-BR" sz="1200" dirty="0" smtClean="0"/>
+              <a:rPr lang="pt-BR" sz="1200" dirty="0"/>
               <a:t>Python/Power BI ou Quicksight</a:t>
             </a:r>
-            <a:endParaRPr lang="pt-BR" sz="1200" dirty="0"/>
           </a:p>
         </p:txBody>
       </p:sp>
@@ -4049,10 +3987,9 @@
           <a:p>
             <a:pPr algn="ctr"/>
             <a:r>
-              <a:rPr lang="pt-BR" sz="1400" dirty="0" smtClean="0"/>
+              <a:rPr lang="pt-BR" sz="1400" dirty="0"/>
               <a:t>C# / ASP.NET /CSS/ HTMl / JS ou Angular</a:t>
             </a:r>
-            <a:endParaRPr lang="pt-BR" sz="1400" dirty="0"/>
           </a:p>
         </p:txBody>
       </p:sp>
@@ -4091,10 +4028,9 @@
           <a:p>
             <a:pPr algn="ctr"/>
             <a:r>
-              <a:rPr lang="pt-BR" sz="1400" dirty="0" smtClean="0"/>
+              <a:rPr lang="pt-BR" sz="1400" dirty="0"/>
               <a:t>Power BI / Python / Quicksight / AWS Serviços</a:t>
             </a:r>
-            <a:endParaRPr lang="pt-BR" sz="1400" dirty="0"/>
           </a:p>
         </p:txBody>
       </p:sp>
@@ -4133,10 +4069,9 @@
           <a:p>
             <a:pPr algn="ctr"/>
             <a:r>
-              <a:rPr lang="pt-BR" sz="1400" dirty="0" smtClean="0"/>
+              <a:rPr lang="pt-BR" sz="1400" dirty="0"/>
               <a:t>TXT / XML</a:t>
             </a:r>
-            <a:endParaRPr lang="pt-BR" sz="1400" dirty="0"/>
           </a:p>
         </p:txBody>
       </p:sp>
@@ -4175,10 +4110,9 @@
           <a:p>
             <a:pPr algn="ctr"/>
             <a:r>
-              <a:rPr lang="pt-BR" sz="1400" dirty="0" smtClean="0"/>
+              <a:rPr lang="pt-BR" sz="1400" dirty="0"/>
               <a:t>API Rest</a:t>
             </a:r>
-            <a:endParaRPr lang="pt-BR" sz="1400" dirty="0"/>
           </a:p>
         </p:txBody>
       </p:sp>
@@ -4205,7 +4139,7 @@
           <a:lstStyle/>
           <a:p>
             <a:r>
-              <a:rPr lang="pt-BR" b="1" dirty="0" smtClean="0">
+              <a:rPr lang="pt-BR" b="1" dirty="0">
                 <a:solidFill>
                   <a:schemeClr val="accent6"/>
                 </a:solidFill>
@@ -4213,7 +4147,7 @@
               <a:t>Banco</a:t>
             </a:r>
             <a:r>
-              <a:rPr lang="pt-BR" b="1" dirty="0" smtClean="0">
+              <a:rPr lang="pt-BR" b="1" dirty="0">
                 <a:solidFill>
                   <a:srgbClr val="C00000"/>
                 </a:solidFill>
@@ -4221,18 +4155,13 @@
               <a:t>S</a:t>
             </a:r>
             <a:r>
-              <a:rPr lang="pt-BR" b="1" dirty="0" smtClean="0">
+              <a:rPr lang="pt-BR" b="1" dirty="0">
                 <a:solidFill>
                   <a:schemeClr val="accent5"/>
                 </a:solidFill>
               </a:rPr>
               <a:t>ENAI</a:t>
             </a:r>
-            <a:endParaRPr lang="pt-BR" b="1" dirty="0">
-              <a:solidFill>
-                <a:schemeClr val="accent5"/>
-              </a:solidFill>
-            </a:endParaRPr>
           </a:p>
         </p:txBody>
       </p:sp>
@@ -4271,10 +4200,9 @@
           <a:p>
             <a:pPr algn="ctr"/>
             <a:r>
-              <a:rPr lang="pt-BR" sz="1400" dirty="0" smtClean="0"/>
+              <a:rPr lang="pt-BR" sz="1400" dirty="0"/>
               <a:t>Angular</a:t>
             </a:r>
-            <a:endParaRPr lang="pt-BR" sz="1400" dirty="0"/>
           </a:p>
         </p:txBody>
       </p:sp>
@@ -4318,18 +4246,13 @@
           <a:p>
             <a:pPr algn="ctr"/>
             <a:r>
-              <a:rPr lang="pt-BR" dirty="0" smtClean="0">
+              <a:rPr lang="pt-BR" dirty="0">
                 <a:solidFill>
                   <a:schemeClr val="tx1"/>
                 </a:solidFill>
               </a:rPr>
               <a:t>TDD</a:t>
             </a:r>
-            <a:endParaRPr lang="pt-BR" dirty="0">
-              <a:solidFill>
-                <a:schemeClr val="tx1"/>
-              </a:solidFill>
-            </a:endParaRPr>
           </a:p>
         </p:txBody>
       </p:sp>
@@ -4424,16 +4347,12 @@
           <a:lstStyle/>
           <a:p>
             <a:r>
-              <a:rPr lang="pt-BR" sz="4000" b="1" dirty="0" smtClean="0">
+              <a:rPr lang="pt-BR" sz="4000" b="1" dirty="0">
                 <a:latin typeface="Arial" panose="020B0604020202020204" pitchFamily="34" charset="0"/>
                 <a:cs typeface="Arial" panose="020B0604020202020204" pitchFamily="34" charset="0"/>
               </a:rPr>
               <a:t>DER INICIAL</a:t>
             </a:r>
-            <a:endParaRPr lang="pt-BR" sz="4000" b="1" dirty="0">
-              <a:latin typeface="Arial" panose="020B0604020202020204" pitchFamily="34" charset="0"/>
-              <a:cs typeface="Arial" panose="020B0604020202020204" pitchFamily="34" charset="0"/>
-            </a:endParaRPr>
           </a:p>
         </p:txBody>
       </p:sp>
@@ -4460,7 +4379,7 @@
           <a:lstStyle/>
           <a:p>
             <a:r>
-              <a:rPr lang="pt-BR" b="1" dirty="0" smtClean="0">
+              <a:rPr lang="pt-BR" b="1" dirty="0">
                 <a:solidFill>
                   <a:schemeClr val="accent6"/>
                 </a:solidFill>
@@ -4468,7 +4387,7 @@
               <a:t>Banco</a:t>
             </a:r>
             <a:r>
-              <a:rPr lang="pt-BR" b="1" dirty="0" smtClean="0">
+              <a:rPr lang="pt-BR" b="1" dirty="0">
                 <a:solidFill>
                   <a:srgbClr val="C00000"/>
                 </a:solidFill>
@@ -4476,18 +4395,13 @@
               <a:t>S</a:t>
             </a:r>
             <a:r>
-              <a:rPr lang="pt-BR" b="1" dirty="0" smtClean="0">
+              <a:rPr lang="pt-BR" b="1" dirty="0">
                 <a:solidFill>
                   <a:schemeClr val="accent5"/>
                 </a:solidFill>
               </a:rPr>
               <a:t>ENAI</a:t>
             </a:r>
-            <a:endParaRPr lang="pt-BR" b="1" dirty="0">
-              <a:solidFill>
-                <a:schemeClr val="accent5"/>
-              </a:solidFill>
-            </a:endParaRPr>
           </a:p>
         </p:txBody>
       </p:sp>
@@ -4543,10 +4457,9 @@
           <a:lstStyle/>
           <a:p>
             <a:r>
-              <a:rPr lang="pt-BR" dirty="0" smtClean="0"/>
+              <a:rPr lang="pt-BR" dirty="0"/>
               <a:t>Movimentação = Transações bancárias</a:t>
             </a:r>
-            <a:endParaRPr lang="pt-BR" dirty="0"/>
           </a:p>
         </p:txBody>
       </p:sp>
@@ -4603,16 +4516,12 @@
           <a:lstStyle/>
           <a:p>
             <a:r>
-              <a:rPr lang="pt-BR" sz="3600" dirty="0" smtClean="0">
+              <a:rPr lang="pt-BR" sz="3600" dirty="0">
                 <a:latin typeface="Arial" panose="020B0604020202020204" pitchFamily="34" charset="0"/>
                 <a:cs typeface="Arial" panose="020B0604020202020204" pitchFamily="34" charset="0"/>
               </a:rPr>
               <a:t>REGRAS DE NEGÓCIO PRINCIPAIS</a:t>
             </a:r>
-            <a:endParaRPr lang="pt-BR" sz="3600" dirty="0">
-              <a:latin typeface="Arial" panose="020B0604020202020204" pitchFamily="34" charset="0"/>
-              <a:cs typeface="Arial" panose="020B0604020202020204" pitchFamily="34" charset="0"/>
-            </a:endParaRPr>
           </a:p>
         </p:txBody>
       </p:sp>
@@ -4639,7 +4548,7 @@
           <a:lstStyle/>
           <a:p>
             <a:r>
-              <a:rPr lang="pt-BR" b="1" dirty="0" smtClean="0">
+              <a:rPr lang="pt-BR" b="1" dirty="0">
                 <a:solidFill>
                   <a:schemeClr val="accent6"/>
                 </a:solidFill>
@@ -4647,7 +4556,7 @@
               <a:t>Banco</a:t>
             </a:r>
             <a:r>
-              <a:rPr lang="pt-BR" b="1" dirty="0" smtClean="0">
+              <a:rPr lang="pt-BR" b="1" dirty="0">
                 <a:solidFill>
                   <a:srgbClr val="C00000"/>
                 </a:solidFill>
@@ -4655,18 +4564,13 @@
               <a:t>S</a:t>
             </a:r>
             <a:r>
-              <a:rPr lang="pt-BR" b="1" dirty="0" smtClean="0">
+              <a:rPr lang="pt-BR" b="1" dirty="0">
                 <a:solidFill>
                   <a:schemeClr val="accent5"/>
                 </a:solidFill>
               </a:rPr>
               <a:t>ENAI</a:t>
             </a:r>
-            <a:endParaRPr lang="pt-BR" b="1" dirty="0">
-              <a:solidFill>
-                <a:schemeClr val="accent5"/>
-              </a:solidFill>
-            </a:endParaRPr>
           </a:p>
         </p:txBody>
       </p:sp>
@@ -4717,11 +4621,11 @@
                     <a:lstStyle/>
                     <a:p>
                       <a:r>
-                        <a:rPr lang="pt-BR" sz="2000" dirty="0" smtClean="0"/>
+                        <a:rPr lang="pt-BR" sz="2000" dirty="0"/>
                         <a:t>REGRA</a:t>
                       </a:r>
                       <a:r>
-                        <a:rPr lang="pt-BR" sz="2000" baseline="0" dirty="0" smtClean="0"/>
+                        <a:rPr lang="pt-BR" sz="2000" baseline="0" dirty="0"/>
                         <a:t>  </a:t>
                       </a:r>
                       <a:endParaRPr lang="pt-BR" sz="2000" dirty="0"/>
@@ -4735,10 +4639,9 @@
                     <a:lstStyle/>
                     <a:p>
                       <a:r>
-                        <a:rPr lang="pt-BR" sz="2000" dirty="0" smtClean="0"/>
+                        <a:rPr lang="pt-BR" sz="2000" dirty="0"/>
                         <a:t>CONCEITO</a:t>
                       </a:r>
-                      <a:endParaRPr lang="pt-BR" sz="2000" dirty="0"/>
                     </a:p>
                   </a:txBody>
                   <a:tcPr/>
@@ -4757,10 +4660,9 @@
                     <a:p>
                       <a:pPr algn="l"/>
                       <a:r>
-                        <a:rPr lang="pt-BR" sz="2000" dirty="0" smtClean="0"/>
+                        <a:rPr lang="pt-BR" sz="2000" dirty="0"/>
                         <a:t>R01</a:t>
                       </a:r>
-                      <a:endParaRPr lang="pt-BR" sz="2000" dirty="0"/>
                     </a:p>
                   </a:txBody>
                   <a:tcPr/>
@@ -4771,15 +4673,15 @@
                     <a:lstStyle/>
                     <a:p>
                       <a:r>
-                        <a:rPr lang="pt-BR" sz="2000" b="1" dirty="0" smtClean="0"/>
+                        <a:rPr lang="pt-BR" sz="2000" b="1" dirty="0"/>
                         <a:t>Abertura</a:t>
                       </a:r>
                       <a:r>
-                        <a:rPr lang="pt-BR" sz="2000" b="1" baseline="0" dirty="0" smtClean="0"/>
+                        <a:rPr lang="pt-BR" sz="2000" b="1" baseline="0" dirty="0"/>
                         <a:t> de Conta Digitalmente </a:t>
                       </a:r>
                       <a:r>
-                        <a:rPr lang="pt-BR" sz="2000" baseline="0" dirty="0" smtClean="0"/>
+                        <a:rPr lang="pt-BR" sz="2000" baseline="0" dirty="0"/>
                         <a:t>– cliente acessa link onde deve informar os dados pessoais.  Ao enviar o status da conta fica em “Em Analise”. Sistema processa fluxo de Validar Abertura de Conta com regras especificas que irá retorna o status Aprovado, ou Reprovado.</a:t>
                       </a:r>
                     </a:p>
@@ -4800,10 +4702,9 @@
                     <a:p>
                       <a:pPr algn="l"/>
                       <a:r>
-                        <a:rPr lang="pt-BR" sz="2000" dirty="0" smtClean="0"/>
+                        <a:rPr lang="pt-BR" sz="2000" dirty="0"/>
                         <a:t>R02</a:t>
                       </a:r>
-                      <a:endParaRPr lang="pt-BR" sz="2000" dirty="0"/>
                     </a:p>
                   </a:txBody>
                   <a:tcPr/>
@@ -4814,7 +4715,7 @@
                     <a:lstStyle/>
                     <a:p>
                       <a:r>
-                        <a:rPr lang="pt-BR" sz="2000" baseline="0" dirty="0" smtClean="0"/>
+                        <a:rPr lang="pt-BR" sz="2000" baseline="0" dirty="0"/>
                         <a:t>Envio PIX – cliente informa chave. Sistema valida se chave existe no banco ou em outro banco via Banco Central (API Externa). Validado , verifica se tem saldo, se sim faz o envio e atualização de saldo.</a:t>
                       </a:r>
                     </a:p>
@@ -4835,10 +4736,9 @@
                     <a:p>
                       <a:pPr algn="l"/>
                       <a:r>
-                        <a:rPr lang="pt-BR" sz="2000" dirty="0" smtClean="0"/>
+                        <a:rPr lang="pt-BR" sz="2000" dirty="0"/>
                         <a:t>R03</a:t>
                       </a:r>
-                      <a:endParaRPr lang="pt-BR" sz="2000" dirty="0"/>
                     </a:p>
                   </a:txBody>
                   <a:tcPr/>
@@ -4849,7 +4749,7 @@
                     <a:lstStyle/>
                     <a:p>
                       <a:r>
-                        <a:rPr lang="pt-BR" sz="2000" baseline="0" dirty="0" smtClean="0"/>
+                        <a:rPr lang="pt-BR" sz="2000" baseline="0" dirty="0"/>
                         <a:t>Empréstimo – são produtos do Banco ofertado para os clientes. O cliente acessar link onde mostrar os valores disponíveis para ele. Informa taxa de juros ao ano e numero de parcelas para serem escolhidas. No final informar o valor a ser pago ao final do pagamento de todas as parcelas aplicadas o juros e opção para CONFIRMAR o empréstimo.</a:t>
                       </a:r>
                     </a:p>
@@ -4870,6 +4770,318 @@
     <p:extLst>
       <p:ext uri="{BB962C8B-B14F-4D97-AF65-F5344CB8AC3E}">
         <p14:creationId xmlns:p14="http://schemas.microsoft.com/office/powerpoint/2010/main" val="655825246"/>
+      </p:ext>
+    </p:extLst>
+  </p:cSld>
+  <p:clrMapOvr>
+    <a:masterClrMapping/>
+  </p:clrMapOvr>
+</p:sld>
+</file>
+
+<file path=ppt/slides/slide4.xml><?xml version="1.0" encoding="utf-8"?>
+<p:sld xmlns:a="http://schemas.openxmlformats.org/drawingml/2006/main" xmlns:r="http://schemas.openxmlformats.org/officeDocument/2006/relationships" xmlns:p="http://schemas.openxmlformats.org/presentationml/2006/main">
+  <p:cSld>
+    <p:spTree>
+      <p:nvGrpSpPr>
+        <p:cNvPr id="1" name="">
+          <a:extLst>
+            <a:ext uri="{FF2B5EF4-FFF2-40B4-BE49-F238E27FC236}">
+              <a16:creationId xmlns:a16="http://schemas.microsoft.com/office/drawing/2014/main" id="{8AE01F9B-7BD2-EC14-A50A-57CED0164E24}"/>
+            </a:ext>
+          </a:extLst>
+        </p:cNvPr>
+        <p:cNvGrpSpPr/>
+        <p:nvPr/>
+      </p:nvGrpSpPr>
+      <p:grpSpPr>
+        <a:xfrm>
+          <a:off x="0" y="0"/>
+          <a:ext cx="0" cy="0"/>
+          <a:chOff x="0" y="0"/>
+          <a:chExt cx="0" cy="0"/>
+        </a:xfrm>
+      </p:grpSpPr>
+      <p:sp>
+        <p:nvSpPr>
+          <p:cNvPr id="2" name="Título 1">
+            <a:extLst>
+              <a:ext uri="{FF2B5EF4-FFF2-40B4-BE49-F238E27FC236}">
+                <a16:creationId xmlns:a16="http://schemas.microsoft.com/office/drawing/2014/main" id="{D58F6847-310F-615C-8729-B20A69683507}"/>
+              </a:ext>
+            </a:extLst>
+          </p:cNvPr>
+          <p:cNvSpPr>
+            <a:spLocks noGrp="1"/>
+          </p:cNvSpPr>
+          <p:nvPr>
+            <p:ph type="ctrTitle"/>
+          </p:nvPr>
+        </p:nvSpPr>
+        <p:spPr>
+          <a:xfrm>
+            <a:off x="0" y="140230"/>
+            <a:ext cx="12192000" cy="717725"/>
+          </a:xfrm>
+        </p:spPr>
+        <p:txBody>
+          <a:bodyPr>
+            <a:normAutofit/>
+          </a:bodyPr>
+          <a:lstStyle/>
+          <a:p>
+            <a:r>
+              <a:rPr lang="pt-BR" sz="3600" dirty="0">
+                <a:latin typeface="Arial" panose="020B0604020202020204" pitchFamily="34" charset="0"/>
+                <a:cs typeface="Arial" panose="020B0604020202020204" pitchFamily="34" charset="0"/>
+              </a:rPr>
+              <a:t>REGRAS DE NEGÓCIO CRUD</a:t>
+            </a:r>
+          </a:p>
+        </p:txBody>
+      </p:sp>
+      <p:sp>
+        <p:nvSpPr>
+          <p:cNvPr id="51" name="CaixaDeTexto 50">
+            <a:extLst>
+              <a:ext uri="{FF2B5EF4-FFF2-40B4-BE49-F238E27FC236}">
+                <a16:creationId xmlns:a16="http://schemas.microsoft.com/office/drawing/2014/main" id="{D414EAA5-5125-6EAE-28DC-455C19FCC473}"/>
+              </a:ext>
+            </a:extLst>
+          </p:cNvPr>
+          <p:cNvSpPr txBox="1"/>
+          <p:nvPr/>
+        </p:nvSpPr>
+        <p:spPr>
+          <a:xfrm>
+            <a:off x="10644719" y="6459034"/>
+            <a:ext cx="1422400" cy="369332"/>
+          </a:xfrm>
+          <a:prstGeom prst="rect">
+            <a:avLst/>
+          </a:prstGeom>
+          <a:noFill/>
+        </p:spPr>
+        <p:txBody>
+          <a:bodyPr wrap="square" rtlCol="0">
+            <a:spAutoFit/>
+          </a:bodyPr>
+          <a:lstStyle/>
+          <a:p>
+            <a:r>
+              <a:rPr lang="pt-BR" b="1" dirty="0">
+                <a:solidFill>
+                  <a:schemeClr val="accent6"/>
+                </a:solidFill>
+              </a:rPr>
+              <a:t>Banco</a:t>
+            </a:r>
+            <a:r>
+              <a:rPr lang="pt-BR" b="1" dirty="0">
+                <a:solidFill>
+                  <a:srgbClr val="C00000"/>
+                </a:solidFill>
+              </a:rPr>
+              <a:t>S</a:t>
+            </a:r>
+            <a:r>
+              <a:rPr lang="pt-BR" b="1" dirty="0">
+                <a:solidFill>
+                  <a:schemeClr val="accent5"/>
+                </a:solidFill>
+              </a:rPr>
+              <a:t>ENAI</a:t>
+            </a:r>
+          </a:p>
+        </p:txBody>
+      </p:sp>
+      <p:graphicFrame>
+        <p:nvGraphicFramePr>
+          <p:cNvPr id="3" name="Tabela 2">
+            <a:extLst>
+              <a:ext uri="{FF2B5EF4-FFF2-40B4-BE49-F238E27FC236}">
+                <a16:creationId xmlns:a16="http://schemas.microsoft.com/office/drawing/2014/main" id="{1F2D5F88-1773-6CE0-B5D3-FB2AB2AD2066}"/>
+              </a:ext>
+            </a:extLst>
+          </p:cNvPr>
+          <p:cNvGraphicFramePr>
+            <a:graphicFrameLocks noGrp="1"/>
+          </p:cNvGraphicFramePr>
+          <p:nvPr>
+            <p:extLst>
+              <p:ext uri="{D42A27DB-BD31-4B8C-83A1-F6EECF244321}">
+                <p14:modId xmlns:p14="http://schemas.microsoft.com/office/powerpoint/2010/main" val="709735269"/>
+              </p:ext>
+            </p:extLst>
+          </p:nvPr>
+        </p:nvGraphicFramePr>
+        <p:xfrm>
+          <a:off x="1132419" y="1075266"/>
+          <a:ext cx="10223500" cy="2194560"/>
+        </p:xfrm>
+        <a:graphic>
+          <a:graphicData uri="http://schemas.openxmlformats.org/drawingml/2006/table">
+            <a:tbl>
+              <a:tblPr firstRow="1" bandRow="1">
+                <a:tableStyleId>{7DF18680-E054-41AD-8BC1-D1AEF772440D}</a:tableStyleId>
+              </a:tblPr>
+              <a:tblGrid>
+                <a:gridCol w="1198066">
+                  <a:extLst>
+                    <a:ext uri="{9D8B030D-6E8A-4147-A177-3AD203B41FA5}">
+                      <a16:colId xmlns:a16="http://schemas.microsoft.com/office/drawing/2014/main" val="4042301403"/>
+                    </a:ext>
+                  </a:extLst>
+                </a:gridCol>
+                <a:gridCol w="9025434">
+                  <a:extLst>
+                    <a:ext uri="{9D8B030D-6E8A-4147-A177-3AD203B41FA5}">
+                      <a16:colId xmlns:a16="http://schemas.microsoft.com/office/drawing/2014/main" val="1527217912"/>
+                    </a:ext>
+                  </a:extLst>
+                </a:gridCol>
+              </a:tblGrid>
+              <a:tr h="370840">
+                <a:tc>
+                  <a:txBody>
+                    <a:bodyPr/>
+                    <a:lstStyle/>
+                    <a:p>
+                      <a:r>
+                        <a:rPr lang="pt-BR" sz="2000" dirty="0"/>
+                        <a:t>REGRA</a:t>
+                      </a:r>
+                      <a:r>
+                        <a:rPr lang="pt-BR" sz="2000" baseline="0" dirty="0"/>
+                        <a:t>  </a:t>
+                      </a:r>
+                      <a:endParaRPr lang="pt-BR" sz="2000" dirty="0"/>
+                    </a:p>
+                  </a:txBody>
+                  <a:tcPr/>
+                </a:tc>
+                <a:tc>
+                  <a:txBody>
+                    <a:bodyPr/>
+                    <a:lstStyle/>
+                    <a:p>
+                      <a:r>
+                        <a:rPr lang="pt-BR" sz="2000" dirty="0"/>
+                        <a:t>CONCEITO</a:t>
+                      </a:r>
+                    </a:p>
+                  </a:txBody>
+                  <a:tcPr/>
+                </a:tc>
+                <a:extLst>
+                  <a:ext uri="{0D108BD9-81ED-4DB2-BD59-A6C34878D82A}">
+                    <a16:rowId xmlns:a16="http://schemas.microsoft.com/office/drawing/2014/main" val="1518820120"/>
+                  </a:ext>
+                </a:extLst>
+              </a:tr>
+              <a:tr h="370840">
+                <a:tc>
+                  <a:txBody>
+                    <a:bodyPr/>
+                    <a:lstStyle/>
+                    <a:p>
+                      <a:pPr algn="l"/>
+                      <a:r>
+                        <a:rPr lang="pt-BR" sz="2000" dirty="0"/>
+                        <a:t>R04</a:t>
+                      </a:r>
+                    </a:p>
+                  </a:txBody>
+                  <a:tcPr/>
+                </a:tc>
+                <a:tc>
+                  <a:txBody>
+                    <a:bodyPr/>
+                    <a:lstStyle/>
+                    <a:p>
+                      <a:r>
+                        <a:rPr lang="pt-BR" sz="2000" b="1" dirty="0"/>
+                        <a:t>CRUD CLIENTE:  </a:t>
+                      </a:r>
+                      <a:r>
+                        <a:rPr lang="pt-BR" sz="2000" b="0" dirty="0"/>
+                        <a:t>deve ser possível cadastrar novos clientes no sistema e fazer operações de atualizações. Para cada cliente deve ter obrigatoriamente o nome, cpf. CodigoAgencia o padrão é 10 e saldoInicial 0,0</a:t>
+                      </a:r>
+                      <a:endParaRPr lang="pt-BR" sz="2000" baseline="0" dirty="0"/>
+                    </a:p>
+                  </a:txBody>
+                  <a:tcPr/>
+                </a:tc>
+                <a:extLst>
+                  <a:ext uri="{0D108BD9-81ED-4DB2-BD59-A6C34878D82A}">
+                    <a16:rowId xmlns:a16="http://schemas.microsoft.com/office/drawing/2014/main" val="3221639578"/>
+                  </a:ext>
+                </a:extLst>
+              </a:tr>
+              <a:tr h="370840">
+                <a:tc>
+                  <a:txBody>
+                    <a:bodyPr/>
+                    <a:lstStyle/>
+                    <a:p>
+                      <a:pPr algn="l"/>
+                      <a:endParaRPr lang="pt-BR" sz="2000" dirty="0"/>
+                    </a:p>
+                  </a:txBody>
+                  <a:tcPr/>
+                </a:tc>
+                <a:tc>
+                  <a:txBody>
+                    <a:bodyPr/>
+                    <a:lstStyle/>
+                    <a:p>
+                      <a:endParaRPr lang="pt-BR" sz="2000" baseline="0" dirty="0"/>
+                    </a:p>
+                  </a:txBody>
+                  <a:tcPr/>
+                </a:tc>
+                <a:extLst>
+                  <a:ext uri="{0D108BD9-81ED-4DB2-BD59-A6C34878D82A}">
+                    <a16:rowId xmlns:a16="http://schemas.microsoft.com/office/drawing/2014/main" val="2158845056"/>
+                  </a:ext>
+                </a:extLst>
+              </a:tr>
+              <a:tr h="370840">
+                <a:tc>
+                  <a:txBody>
+                    <a:bodyPr/>
+                    <a:lstStyle/>
+                    <a:p>
+                      <a:pPr algn="l"/>
+                      <a:endParaRPr lang="pt-BR" sz="2000" dirty="0"/>
+                    </a:p>
+                  </a:txBody>
+                  <a:tcPr/>
+                </a:tc>
+                <a:tc>
+                  <a:txBody>
+                    <a:bodyPr/>
+                    <a:lstStyle/>
+                    <a:p>
+                      <a:endParaRPr lang="pt-BR" sz="2000" baseline="0" dirty="0"/>
+                    </a:p>
+                  </a:txBody>
+                  <a:tcPr/>
+                </a:tc>
+                <a:extLst>
+                  <a:ext uri="{0D108BD9-81ED-4DB2-BD59-A6C34878D82A}">
+                    <a16:rowId xmlns:a16="http://schemas.microsoft.com/office/drawing/2014/main" val="3817474440"/>
+                  </a:ext>
+                </a:extLst>
+              </a:tr>
+            </a:tbl>
+          </a:graphicData>
+        </a:graphic>
+      </p:graphicFrame>
+    </p:spTree>
+    <p:extLst>
+      <p:ext uri="{BB962C8B-B14F-4D97-AF65-F5344CB8AC3E}">
+        <p14:creationId xmlns:p14="http://schemas.microsoft.com/office/powerpoint/2010/main" val="3681218908"/>
       </p:ext>
     </p:extLst>
   </p:cSld>

</xml_diff>

<commit_message>
Estrutura do Lab01 Inicial
</commit_message>
<xml_diff>
--- a/Documentacao/ArquiteturaProjeto.pptx
+++ b/Documentacao/ArquiteturaProjeto.pptx
@@ -244,7 +244,7 @@
           <a:p>
             <a:fld id="{F3723911-63F9-4D1B-B658-668BA8A96493}" type="datetimeFigureOut">
               <a:rPr lang="pt-BR" smtClean="0"/>
-              <a:t>10/06/2026</a:t>
+              <a:t>21/06/2026</a:t>
             </a:fld>
             <a:endParaRPr lang="pt-BR"/>
           </a:p>
@@ -412,7 +412,7 @@
           <a:p>
             <a:fld id="{F3723911-63F9-4D1B-B658-668BA8A96493}" type="datetimeFigureOut">
               <a:rPr lang="pt-BR" smtClean="0"/>
-              <a:t>10/06/2026</a:t>
+              <a:t>21/06/2026</a:t>
             </a:fld>
             <a:endParaRPr lang="pt-BR"/>
           </a:p>
@@ -590,7 +590,7 @@
           <a:p>
             <a:fld id="{F3723911-63F9-4D1B-B658-668BA8A96493}" type="datetimeFigureOut">
               <a:rPr lang="pt-BR" smtClean="0"/>
-              <a:t>10/06/2026</a:t>
+              <a:t>21/06/2026</a:t>
             </a:fld>
             <a:endParaRPr lang="pt-BR"/>
           </a:p>
@@ -758,7 +758,7 @@
           <a:p>
             <a:fld id="{F3723911-63F9-4D1B-B658-668BA8A96493}" type="datetimeFigureOut">
               <a:rPr lang="pt-BR" smtClean="0"/>
-              <a:t>10/06/2026</a:t>
+              <a:t>21/06/2026</a:t>
             </a:fld>
             <a:endParaRPr lang="pt-BR"/>
           </a:p>
@@ -1003,7 +1003,7 @@
           <a:p>
             <a:fld id="{F3723911-63F9-4D1B-B658-668BA8A96493}" type="datetimeFigureOut">
               <a:rPr lang="pt-BR" smtClean="0"/>
-              <a:t>10/06/2026</a:t>
+              <a:t>21/06/2026</a:t>
             </a:fld>
             <a:endParaRPr lang="pt-BR"/>
           </a:p>
@@ -1232,7 +1232,7 @@
           <a:p>
             <a:fld id="{F3723911-63F9-4D1B-B658-668BA8A96493}" type="datetimeFigureOut">
               <a:rPr lang="pt-BR" smtClean="0"/>
-              <a:t>10/06/2026</a:t>
+              <a:t>21/06/2026</a:t>
             </a:fld>
             <a:endParaRPr lang="pt-BR"/>
           </a:p>
@@ -1596,7 +1596,7 @@
           <a:p>
             <a:fld id="{F3723911-63F9-4D1B-B658-668BA8A96493}" type="datetimeFigureOut">
               <a:rPr lang="pt-BR" smtClean="0"/>
-              <a:t>10/06/2026</a:t>
+              <a:t>21/06/2026</a:t>
             </a:fld>
             <a:endParaRPr lang="pt-BR"/>
           </a:p>
@@ -1713,7 +1713,7 @@
           <a:p>
             <a:fld id="{F3723911-63F9-4D1B-B658-668BA8A96493}" type="datetimeFigureOut">
               <a:rPr lang="pt-BR" smtClean="0"/>
-              <a:t>10/06/2026</a:t>
+              <a:t>21/06/2026</a:t>
             </a:fld>
             <a:endParaRPr lang="pt-BR"/>
           </a:p>
@@ -1808,7 +1808,7 @@
           <a:p>
             <a:fld id="{F3723911-63F9-4D1B-B658-668BA8A96493}" type="datetimeFigureOut">
               <a:rPr lang="pt-BR" smtClean="0"/>
-              <a:t>10/06/2026</a:t>
+              <a:t>21/06/2026</a:t>
             </a:fld>
             <a:endParaRPr lang="pt-BR"/>
           </a:p>
@@ -2083,7 +2083,7 @@
           <a:p>
             <a:fld id="{F3723911-63F9-4D1B-B658-668BA8A96493}" type="datetimeFigureOut">
               <a:rPr lang="pt-BR" smtClean="0"/>
-              <a:t>10/06/2026</a:t>
+              <a:t>21/06/2026</a:t>
             </a:fld>
             <a:endParaRPr lang="pt-BR"/>
           </a:p>
@@ -2335,7 +2335,7 @@
           <a:p>
             <a:fld id="{F3723911-63F9-4D1B-B658-668BA8A96493}" type="datetimeFigureOut">
               <a:rPr lang="pt-BR" smtClean="0"/>
-              <a:t>10/06/2026</a:t>
+              <a:t>21/06/2026</a:t>
             </a:fld>
             <a:endParaRPr lang="pt-BR"/>
           </a:p>
@@ -2546,7 +2546,7 @@
           <a:p>
             <a:fld id="{F3723911-63F9-4D1B-B658-668BA8A96493}" type="datetimeFigureOut">
               <a:rPr lang="pt-BR" smtClean="0"/>
-              <a:t>10/06/2026</a:t>
+              <a:t>21/06/2026</a:t>
             </a:fld>
             <a:endParaRPr lang="pt-BR"/>
           </a:p>
@@ -4201,7 +4201,7 @@
             <a:pPr algn="ctr"/>
             <a:r>
               <a:rPr lang="pt-BR" sz="1400" dirty="0"/>
-              <a:t>Angular</a:t>
+              <a:t>JS/CSS/HTML</a:t>
             </a:r>
           </a:p>
         </p:txBody>
@@ -4294,6 +4294,53 @@
           </a:fontRef>
         </p:style>
       </p:cxnSp>
+      <p:sp>
+        <p:nvSpPr>
+          <p:cNvPr id="3" name="Retângulo 2">
+            <a:extLst>
+              <a:ext uri="{FF2B5EF4-FFF2-40B4-BE49-F238E27FC236}">
+                <a16:creationId xmlns:a16="http://schemas.microsoft.com/office/drawing/2014/main" id="{4171B702-96BA-A5DB-27D2-9AB9D3FF3FD0}"/>
+              </a:ext>
+            </a:extLst>
+          </p:cNvPr>
+          <p:cNvSpPr/>
+          <p:nvPr/>
+        </p:nvSpPr>
+        <p:spPr>
+          <a:xfrm>
+            <a:off x="8421510" y="6124559"/>
+            <a:ext cx="1219200" cy="302194"/>
+          </a:xfrm>
+          <a:prstGeom prst="rect">
+            <a:avLst/>
+          </a:prstGeom>
+        </p:spPr>
+        <p:style>
+          <a:lnRef idx="1">
+            <a:schemeClr val="accent2"/>
+          </a:lnRef>
+          <a:fillRef idx="2">
+            <a:schemeClr val="accent2"/>
+          </a:fillRef>
+          <a:effectRef idx="1">
+            <a:schemeClr val="accent2"/>
+          </a:effectRef>
+          <a:fontRef idx="minor">
+            <a:schemeClr val="dk1"/>
+          </a:fontRef>
+        </p:style>
+        <p:txBody>
+          <a:bodyPr rtlCol="0" anchor="ctr"/>
+          <a:lstStyle/>
+          <a:p>
+            <a:pPr algn="ctr"/>
+            <a:r>
+              <a:rPr lang="pt-BR" sz="1400" dirty="0"/>
+              <a:t>FRONTEND</a:t>
+            </a:r>
+          </a:p>
+        </p:txBody>
+      </p:sp>
     </p:spTree>
     <p:extLst>
       <p:ext uri="{BB962C8B-B14F-4D97-AF65-F5344CB8AC3E}">
@@ -4910,14 +4957,14 @@
           <p:nvPr>
             <p:extLst>
               <p:ext uri="{D42A27DB-BD31-4B8C-83A1-F6EECF244321}">
-                <p14:modId xmlns:p14="http://schemas.microsoft.com/office/powerpoint/2010/main" val="709735269"/>
+                <p14:modId xmlns:p14="http://schemas.microsoft.com/office/powerpoint/2010/main" val="558456826"/>
               </p:ext>
             </p:extLst>
           </p:nvPr>
         </p:nvGraphicFramePr>
         <p:xfrm>
           <a:off x="1132419" y="1075266"/>
-          <a:ext cx="10223500" cy="2194560"/>
+          <a:ext cx="10223500" cy="5242560"/>
         </p:xfrm>
         <a:graphic>
           <a:graphicData uri="http://schemas.openxmlformats.org/drawingml/2006/table">
@@ -5000,14 +5047,13 @@
                     <a:lstStyle/>
                     <a:p>
                       <a:r>
-                        <a:rPr lang="pt-BR" sz="2000" b="1" dirty="0"/>
-                        <a:t>CRUD CLIENTE:  </a:t>
+                        <a:rPr lang="pt-BR" sz="2000" b="1" baseline="0" dirty="0"/>
+                        <a:t>CRUD AGÊNCIA</a:t>
                       </a:r>
                       <a:r>
-                        <a:rPr lang="pt-BR" sz="2000" b="0" dirty="0"/>
-                        <a:t>deve ser possível cadastrar novos clientes no sistema e fazer operações de atualizações. Para cada cliente deve ter obrigatoriamente o nome, cpf. CodigoAgencia o padrão é 10 e saldoInicial 0,0</a:t>
+                        <a:rPr lang="pt-BR" sz="2000" baseline="0" dirty="0"/>
+                        <a:t>: O BANCOSENAI contém várias agências distribuídas em todas as unidades da federação. Desse modo, deve ser possível cadastrar, alterar, pesquisar e excluir dados das agências. Para cada agência deve ser possível visualizar o Número da agencia, cidade que está situada e Sigla do estado</a:t>
                       </a:r>
-                      <a:endParaRPr lang="pt-BR" sz="2000" baseline="0" dirty="0"/>
                     </a:p>
                   </a:txBody>
                   <a:tcPr/>
@@ -5024,8 +5070,27 @@
                     <a:bodyPr/>
                     <a:lstStyle/>
                     <a:p>
-                      <a:pPr algn="l"/>
-                      <a:endParaRPr lang="pt-BR" sz="2000" dirty="0"/>
+                      <a:pPr marL="0" marR="0" lvl="0" indent="0" algn="l" defTabSz="914400" rtl="0" eaLnBrk="1" fontAlgn="auto" latinLnBrk="0" hangingPunct="1">
+                        <a:lnSpc>
+                          <a:spcPct val="100000"/>
+                        </a:lnSpc>
+                        <a:spcBef>
+                          <a:spcPts val="0"/>
+                        </a:spcBef>
+                        <a:spcAft>
+                          <a:spcPts val="0"/>
+                        </a:spcAft>
+                        <a:buClrTx/>
+                        <a:buSzTx/>
+                        <a:buFontTx/>
+                        <a:buNone/>
+                        <a:tabLst/>
+                        <a:defRPr/>
+                      </a:pPr>
+                      <a:r>
+                        <a:rPr lang="pt-BR" sz="2000" dirty="0"/>
+                        <a:t>R05</a:t>
+                      </a:r>
                     </a:p>
                   </a:txBody>
                   <a:tcPr/>
@@ -5035,6 +5100,14 @@
                     <a:bodyPr/>
                     <a:lstStyle/>
                     <a:p>
+                      <a:r>
+                        <a:rPr lang="pt-BR" sz="2000" b="1" dirty="0"/>
+                        <a:t>CRUD CARTEIRA: </a:t>
+                      </a:r>
+                      <a:r>
+                        <a:rPr lang="pt-BR" sz="2000" b="0" dirty="0"/>
+                        <a:t>no sistema financeira carteira é uma forma de classificar o tipo de cliente. Exemplo de carteira são Agro, Varejo, Atacado. O banco ele tem um apetite por carteira. Esse apetite é o valor em decimal de quanto cada carteira deve ter para considerar uma carteira saudável. Um apetite de 1Bilhão significa que o esperado da soma de todos os saldos de contas nessa carteira esteja acima desse valor. Para cada carteira precisamos do Número, Nome e Apetite. O valor inicial do apetite é de 1milhão para cada carteira.</a:t>
+                      </a:r>
                       <a:endParaRPr lang="pt-BR" sz="2000" baseline="0" dirty="0"/>
                     </a:p>
                   </a:txBody>
@@ -5042,7 +5115,7 @@
                 </a:tc>
                 <a:extLst>
                   <a:ext uri="{0D108BD9-81ED-4DB2-BD59-A6C34878D82A}">
-                    <a16:rowId xmlns:a16="http://schemas.microsoft.com/office/drawing/2014/main" val="2158845056"/>
+                    <a16:rowId xmlns:a16="http://schemas.microsoft.com/office/drawing/2014/main" val="3817474440"/>
                   </a:ext>
                 </a:extLst>
               </a:tr>
@@ -5053,7 +5126,10 @@
                     <a:lstStyle/>
                     <a:p>
                       <a:pPr algn="l"/>
-                      <a:endParaRPr lang="pt-BR" sz="2000" dirty="0"/>
+                      <a:r>
+                        <a:rPr lang="pt-BR" sz="2000" dirty="0"/>
+                        <a:t>R06</a:t>
+                      </a:r>
                     </a:p>
                   </a:txBody>
                   <a:tcPr/>
@@ -5063,6 +5139,31 @@
                     <a:bodyPr/>
                     <a:lstStyle/>
                     <a:p>
+                      <a:pPr marL="0" marR="0" lvl="0" indent="0" algn="l" defTabSz="914400" rtl="0" eaLnBrk="1" fontAlgn="auto" latinLnBrk="0" hangingPunct="1">
+                        <a:lnSpc>
+                          <a:spcPct val="100000"/>
+                        </a:lnSpc>
+                        <a:spcBef>
+                          <a:spcPts val="0"/>
+                        </a:spcBef>
+                        <a:spcAft>
+                          <a:spcPts val="0"/>
+                        </a:spcAft>
+                        <a:buClrTx/>
+                        <a:buSzTx/>
+                        <a:buFontTx/>
+                        <a:buNone/>
+                        <a:tabLst/>
+                        <a:defRPr/>
+                      </a:pPr>
+                      <a:r>
+                        <a:rPr lang="pt-BR" sz="2000" b="1" dirty="0"/>
+                        <a:t>CRUD CLIENTE:  </a:t>
+                      </a:r>
+                      <a:r>
+                        <a:rPr lang="pt-BR" sz="2000" b="0" dirty="0"/>
+                        <a:t>deve ser possível cadastrar novos clientes no sistema e fazer operações de atualizações. Para cada cliente deve ter obrigatoriamente Código  (automático pelo sistema), nome, cpf, Numero da Agência o padrão é 10 e saldo total no banco  0,0.  Esse saldo </a:t>
+                      </a:r>
                       <a:endParaRPr lang="pt-BR" sz="2000" baseline="0" dirty="0"/>
                     </a:p>
                   </a:txBody>
@@ -5070,7 +5171,7 @@
                 </a:tc>
                 <a:extLst>
                   <a:ext uri="{0D108BD9-81ED-4DB2-BD59-A6C34878D82A}">
-                    <a16:rowId xmlns:a16="http://schemas.microsoft.com/office/drawing/2014/main" val="3817474440"/>
+                    <a16:rowId xmlns:a16="http://schemas.microsoft.com/office/drawing/2014/main" val="4101843646"/>
                   </a:ext>
                 </a:extLst>
               </a:tr>

</xml_diff>

<commit_message>
Documento atualizado com regra de Segurança
</commit_message>
<xml_diff>
--- a/Documentacao/ArquiteturaProjeto.pptx
+++ b/Documentacao/ArquiteturaProjeto.pptx
@@ -5241,14 +5241,14 @@
           <p:nvPr>
             <p:extLst>
               <p:ext uri="{D42A27DB-BD31-4B8C-83A1-F6EECF244321}">
-                <p14:modId xmlns:p14="http://schemas.microsoft.com/office/powerpoint/2010/main" val="741343900"/>
+                <p14:modId xmlns:p14="http://schemas.microsoft.com/office/powerpoint/2010/main" val="24196229"/>
               </p:ext>
             </p:extLst>
           </p:nvPr>
         </p:nvGraphicFramePr>
         <p:xfrm>
           <a:off x="1132419" y="1075266"/>
-          <a:ext cx="10223500" cy="2804160"/>
+          <a:ext cx="10223500" cy="2499360"/>
         </p:xfrm>
         <a:graphic>
           <a:graphicData uri="http://schemas.openxmlformats.org/drawingml/2006/table">
@@ -5336,7 +5336,7 @@
                       </a:r>
                       <a:r>
                         <a:rPr lang="pt-BR" sz="2000" baseline="0" dirty="0"/>
-                        <a:t>– A segurança de acesso é conta tornou-se um requisito básico de negócio a medida que o numero de golpes de acesso indevidas a contas bancárias foram aumentando. Você deve implementar um mecanismo detectar se quem esta acessando a conta via aplicativo é a pessoa real ou um possível fraudulento. </a:t>
+                        <a:t>– O sistema deve implementar um mecanismo detectar se quem esta acessando a conta via aplicativo é a pessoa real ou um possível fraudulento de forma faço bloqueio imediato quando dados de credenciais forem passados de forma incorreta.</a:t>
                       </a:r>
                     </a:p>
                   </a:txBody>

</xml_diff>